<commit_message>
W02/D1: the SQL files renumbered into round order, 01 to 03 the rounds, 04 the case, 05 the lab, 06 the take-home
Every reference follows: the notebooks' block readers, re-executed; both decks, rebuilt; the
exercises, the companion's foot, the study notes, the day sheet and the provenance.

Co-Authored-By: Claude Opus 5.5 <noreply@anthropic.com>
Claude-Session: https://claude.ai/code/session_01VC5W7GojYFfjjm5LnFjvrj
</commit_message>
<xml_diff>
--- a/content/W02/D1/slides/C2_W02_D01_half1_STUDENT.pptx
+++ b/content/W02/D1/slides/C2_W02_D01_half1_STUDENT.pptx
@@ -1802,7 +1802,7 @@
           </a:p>
           <a:p>
             <a:r>
-              <a:t>Notebook: notebooks/C2_W02_D01_02_segments_STUDENT.ipynb. SQL: sql/C2_W02_D01_03_segments_STUDENT.sql.</a:t>
+              <a:t>Notebook: notebooks/C2_W02_D01_02_segments_STUDENT.ipynb. SQL: sql/C2_W02_D01_02_segments_STUDENT.sql.</a:t>
             </a:r>
           </a:p>
         </p:txBody>
@@ -2727,7 +2727,7 @@
           </a:p>
           <a:p>
             <a:r>
-              <a:t>Notebook: notebooks/C2_W02_D01_03_quarters_STUDENT.ipynb. SQL: sql/C2_W02_D01_04_quarters_STUDENT.sql.</a:t>
+              <a:t>Notebook: notebooks/C2_W02_D01_03_quarters_STUDENT.ipynb. SQL: sql/C2_W02_D01_03_quarters_STUDENT.sql.</a:t>
             </a:r>
           </a:p>
         </p:txBody>

</xml_diff>

<commit_message>
W02/D1: round 1's SQL file renamed 01_warehouse to match its notebook
Every reference follows: notebook 1's block reader, re-executed; the morning deck, rebuilt; the
round 1 set, the board work, the day sheet and the provenance.

Co-Authored-By: Claude Opus 5.5 <noreply@anthropic.com>
Claude-Session: https://claude.ai/code/session_01VC5W7GojYFfjjm5LnFjvrj
</commit_message>
<xml_diff>
--- a/content/W02/D1/slides/C2_W02_D01_half1_STUDENT.pptx
+++ b/content/W02/D1/slides/C2_W02_D01_half1_STUDENT.pptx
@@ -647,7 +647,7 @@
           </a:p>
           <a:p>
             <a:r>
-              <a:t>Notebook: notebooks/C2_W02_D01_01_warehouse_STUDENT.ipynb. SQL: sql/C2_W02_D01_01_first_queries_STUDENT.sql.</a:t>
+              <a:t>Notebook: notebooks/C2_W02_D01_01_warehouse_STUDENT.ipynb. SQL: sql/C2_W02_D01_01_warehouse_STUDENT.sql.</a:t>
             </a:r>
           </a:p>
         </p:txBody>
@@ -9790,7 +9790,7 @@
                 </a:solidFill>
                 <a:latin typeface="Calibri"/>
               </a:rPr>
-              <a:t>sql/C2_W02_D01_01_first_queries_STUDENT.sql, one block per question.</a:t>
+              <a:t>sql/C2_W02_D01_01_warehouse_STUDENT.sql, one block per question.</a:t>
             </a:r>
           </a:p>
         </p:txBody>

</xml_diff>

<commit_message>
Week 2 Monday: Anand Iyer is the finance controller throughout, decks rebuilt
Eighteen mentions across the decks, notebooks, exercises, pre-read, study notes and demo page now
read finance controller, per the requester's decision of 30 September 2026. Both decks are rebuilt
from their markdown, and the provenance row records the decision in place of following the row.

Co-Authored-By: Claude Opus 5.5 <noreply@anthropic.com>
Claude-Session: https://claude.ai/code/session_01P7zaoR4dQ5pzBFnsX549JQ
</commit_message>
<xml_diff>
--- a/content/W02/D1/slides/C2_W02_D01_half1_STUDENT.pptx
+++ b/content/W02/D1/slides/C2_W02_D01_half1_STUDENT.pptx
@@ -2279,7 +2279,7 @@
           <a:lstStyle/>
           <a:p>
             <a:r>
-              <a:t>LIVE, 3 minutes. The stats row is the brief. Anand is the CFO of Kalpa Retail; his analyst will</a:t>
+              <a:t>LIVE, 3 minutes. The stats row is the brief. Anand is the finance controller of Kalpa Retail; his analyst will</a:t>
             </a:r>
           </a:p>
           <a:p>
@@ -7542,7 +7542,7 @@
                 </a:solidFill>
                 <a:latin typeface="Calibri"/>
               </a:rPr>
-              <a:t>Anand Iyer, CFO, Kalpa Retail, to the data and AI team at Kalpa's Global Capability Centre</a:t>
+              <a:t>Anand Iyer, finance controller, Kalpa Retail, to the data and AI team at Kalpa's Global Capability Centre</a:t>
             </a:r>
           </a:p>
         </p:txBody>
@@ -8706,7 +8706,7 @@
       </p:sp>
       <p:pic>
         <p:nvPicPr>
-          <p:cNvPr id="9" name="mermaid diagram" descr="5e9d1ecb47b31b1f.png"/>
+          <p:cNvPr id="9" name="mermaid diagram" descr="e7c248840fa66f42.png"/>
           <p:cNvPicPr>
             <a:picLocks noChangeAspect="1"/>
           </p:cNvPicPr>
@@ -12085,7 +12085,7 @@
       </p:sp>
       <p:pic>
         <p:nvPicPr>
-          <p:cNvPr id="9" name="mermaid diagram" descr="a782461c018ec3e6.png"/>
+          <p:cNvPr id="9" name="mermaid diagram" descr="f67cf520115efb24.png"/>
           <p:cNvPicPr>
             <a:picLocks noChangeAspect="1"/>
           </p:cNvPicPr>
@@ -12838,7 +12838,7 @@
       </p:sp>
       <p:pic>
         <p:nvPicPr>
-          <p:cNvPr id="9" name="mermaid diagram" descr="f3cbf4beecfb898f.png"/>
+          <p:cNvPr id="9" name="mermaid diagram" descr="e272f82bf407a28a.png"/>
           <p:cNvPicPr>
             <a:picLocks noChangeAspect="1"/>
           </p:cNvPicPr>
@@ -15008,7 +15008,7 @@
       </p:sp>
       <p:pic>
         <p:nvPicPr>
-          <p:cNvPr id="9" name="mermaid diagram" descr="06b369e26be94eec.png"/>
+          <p:cNvPr id="9" name="mermaid diagram" descr="ca4d9ff7fdbba2e0.png"/>
           <p:cNvPicPr>
             <a:picLocks noChangeAspect="1"/>
           </p:cNvPicPr>
@@ -16959,7 +16959,7 @@
       </p:sp>
       <p:pic>
         <p:nvPicPr>
-          <p:cNvPr id="9" name="mermaid diagram" descr="30c75ebcae7f2f56.png"/>
+          <p:cNvPr id="9" name="mermaid diagram" descr="dfbc2890ccb16d85.png"/>
           <p:cNvPicPr>
             <a:picLocks noChangeAspect="1"/>
           </p:cNvPicPr>
@@ -17740,7 +17740,7 @@
                 </a:solidFill>
                 <a:latin typeface="Calibri"/>
               </a:rPr>
-              <a:t>The CFO wants last week's tree every Monday, from the warehouse, and an analyst who audits every line.</a:t>
+              <a:t>The finance controller wants last week's tree every Monday, from the warehouse, and an analyst who audits every line.</a:t>
             </a:r>
           </a:p>
         </p:txBody>
@@ -18278,7 +18278,7 @@
       </p:sp>
       <p:pic>
         <p:nvPicPr>
-          <p:cNvPr id="9" name="mermaid diagram" descr="77f46e32dac38567.png"/>
+          <p:cNvPr id="9" name="mermaid diagram" descr="6a7c30b4937cbfbe.png"/>
           <p:cNvPicPr>
             <a:picLocks noChangeAspect="1"/>
           </p:cNvPicPr>
@@ -20262,7 +20262,7 @@
       </p:graphicFrame>
       <p:pic>
         <p:nvPicPr>
-          <p:cNvPr id="10" name="mermaid diagram" descr="93ad4fa194c1b7da.png"/>
+          <p:cNvPr id="10" name="mermaid diagram" descr="6a39d33904fb82bc.png"/>
           <p:cNvPicPr>
             <a:picLocks noChangeAspect="1"/>
           </p:cNvPicPr>
@@ -21948,7 +21948,7 @@
       </p:sp>
       <p:pic>
         <p:nvPicPr>
-          <p:cNvPr id="9" name="mermaid diagram" descr="6d288b596ca0b339.png"/>
+          <p:cNvPr id="9" name="mermaid diagram" descr="82c63a5263e0ed74.png"/>
           <p:cNvPicPr>
             <a:picLocks noChangeAspect="1"/>
           </p:cNvPicPr>
@@ -22701,7 +22701,7 @@
       </p:sp>
       <p:pic>
         <p:nvPicPr>
-          <p:cNvPr id="9" name="mermaid diagram" descr="a2110e9e7deb753a.png"/>
+          <p:cNvPr id="9" name="mermaid diagram" descr="d8aaba855403f768.png"/>
           <p:cNvPicPr>
             <a:picLocks noChangeAspect="1"/>
           </p:cNvPicPr>
@@ -24265,7 +24265,7 @@
       </p:sp>
       <p:pic>
         <p:nvPicPr>
-          <p:cNvPr id="9" name="mermaid diagram" descr="096ef5ab22fa8367.png"/>
+          <p:cNvPr id="9" name="mermaid diagram" descr="5b85e490a82d7692.png"/>
           <p:cNvPicPr>
             <a:picLocks noChangeAspect="1"/>
           </p:cNvPicPr>
@@ -25349,7 +25349,7 @@
       </p:sp>
       <p:pic>
         <p:nvPicPr>
-          <p:cNvPr id="14" name="mermaid diagram" descr="b74f5781e730b113.png"/>
+          <p:cNvPr id="14" name="mermaid diagram" descr="29a32aba4ab76b8f.png"/>
           <p:cNvPicPr>
             <a:picLocks noChangeAspect="1"/>
           </p:cNvPicPr>
@@ -29169,7 +29169,7 @@
       </p:sp>
       <p:pic>
         <p:nvPicPr>
-          <p:cNvPr id="9" name="mermaid diagram" descr="776de219dc4df376.png"/>
+          <p:cNvPr id="9" name="mermaid diagram" descr="1db3360a4e13015a.png"/>
           <p:cNvPicPr>
             <a:picLocks noChangeAspect="1"/>
           </p:cNvPicPr>
@@ -31137,7 +31137,7 @@
       </p:sp>
       <p:pic>
         <p:nvPicPr>
-          <p:cNvPr id="9" name="mermaid diagram" descr="9b66a5e9566aa2ff.png"/>
+          <p:cNvPr id="9" name="mermaid diagram" descr="3f7a11a5bfa1a2d8.png"/>
           <p:cNvPicPr>
             <a:picLocks noChangeAspect="1"/>
           </p:cNvPicPr>
@@ -31787,7 +31787,7 @@
       </p:sp>
       <p:pic>
         <p:nvPicPr>
-          <p:cNvPr id="9" name="mermaid diagram" descr="bab6c3304ce5a213.png"/>
+          <p:cNvPr id="9" name="mermaid diagram" descr="cfd59792554dbf7a.png"/>
           <p:cNvPicPr>
             <a:picLocks noChangeAspect="1"/>
           </p:cNvPicPr>
@@ -33636,7 +33636,7 @@
       </p:sp>
       <p:pic>
         <p:nvPicPr>
-          <p:cNvPr id="9" name="mermaid diagram" descr="99f9ea1747753ad0.png"/>
+          <p:cNvPr id="9" name="mermaid diagram" descr="2818a7dafb2e0f8d.png"/>
           <p:cNvPicPr>
             <a:picLocks noChangeAspect="1"/>
           </p:cNvPicPr>
@@ -35200,7 +35200,7 @@
       </p:sp>
       <p:pic>
         <p:nvPicPr>
-          <p:cNvPr id="9" name="mermaid diagram" descr="230c8d2ddee8bc43.png"/>
+          <p:cNvPr id="9" name="mermaid diagram" descr="a57db559aeeceb75.png"/>
           <p:cNvPicPr>
             <a:picLocks noChangeAspect="1"/>
           </p:cNvPicPr>
@@ -36013,7 +36013,7 @@
       </p:sp>
       <p:pic>
         <p:nvPicPr>
-          <p:cNvPr id="9" name="mermaid diagram" descr="fef96764c24f63c4.png"/>
+          <p:cNvPr id="9" name="mermaid diagram" descr="0e5464ea88ae9e98.png"/>
           <p:cNvPicPr>
             <a:picLocks noChangeAspect="1"/>
           </p:cNvPicPr>
@@ -38922,7 +38922,7 @@
       </p:sp>
       <p:pic>
         <p:nvPicPr>
-          <p:cNvPr id="9" name="mermaid diagram" descr="49cc1c6876eb26ca.png"/>
+          <p:cNvPr id="9" name="mermaid diagram" descr="d30e79d1fd0c5839.png"/>
           <p:cNvPicPr>
             <a:picLocks noChangeAspect="1"/>
           </p:cNvPicPr>
@@ -42663,7 +42663,7 @@
       </p:sp>
       <p:pic>
         <p:nvPicPr>
-          <p:cNvPr id="9" name="mermaid diagram" descr="85613595a8e7c451.png"/>
+          <p:cNvPr id="9" name="mermaid diagram" descr="eec574208616d404.png"/>
           <p:cNvPicPr>
             <a:picLocks noChangeAspect="1"/>
           </p:cNvPicPr>
@@ -43313,7 +43313,7 @@
       </p:sp>
       <p:pic>
         <p:nvPicPr>
-          <p:cNvPr id="9" name="mermaid diagram" descr="a1956adad251ade1.png"/>
+          <p:cNvPr id="9" name="mermaid diagram" descr="86a21c4df1fea7eb.png"/>
           <p:cNvPicPr>
             <a:picLocks noChangeAspect="1"/>
           </p:cNvPicPr>
@@ -45384,7 +45384,7 @@
       </p:sp>
       <p:pic>
         <p:nvPicPr>
-          <p:cNvPr id="9" name="mermaid diagram" descr="446f523db9d29fe4.png"/>
+          <p:cNvPr id="9" name="mermaid diagram" descr="ea01e4a5615f05d1.png"/>
           <p:cNvPicPr>
             <a:picLocks noChangeAspect="1"/>
           </p:cNvPicPr>
@@ -46382,7 +46382,7 @@
       </p:sp>
       <p:pic>
         <p:nvPicPr>
-          <p:cNvPr id="9" name="mermaid diagram" descr="c25ba27c6ab31169.png"/>
+          <p:cNvPr id="9" name="mermaid diagram" descr="8802efd238fb2702.png"/>
           <p:cNvPicPr>
             <a:picLocks noChangeAspect="1"/>
           </p:cNvPicPr>
@@ -48285,7 +48285,7 @@
       </p:sp>
       <p:pic>
         <p:nvPicPr>
-          <p:cNvPr id="9" name="mermaid diagram" descr="3768ea64a5341b91.png"/>
+          <p:cNvPr id="9" name="mermaid diagram" descr="2b96b1f67cbf317d.png"/>
           <p:cNvPicPr>
             <a:picLocks noChangeAspect="1"/>
           </p:cNvPicPr>
@@ -48940,7 +48940,7 @@
       </p:sp>
       <p:pic>
         <p:nvPicPr>
-          <p:cNvPr id="9" name="mermaid diagram" descr="882d21cbe8d7fe3b.png"/>
+          <p:cNvPr id="9" name="mermaid diagram" descr="3024a9241b3fa06f.png"/>
           <p:cNvPicPr>
             <a:picLocks noChangeAspect="1"/>
           </p:cNvPicPr>

</xml_diff>